<commit_message>
feat: implémentation architecture agentique et dialogue itératif
</commit_message>
<xml_diff>
--- a/Presentation1.pptx
+++ b/Presentation1.pptx
@@ -271,7 +271,7 @@
           <a:p>
             <a:fld id="{C160A1AF-E65B-EC4B-9788-C7116365DFF5}" type="datetimeFigureOut">
               <a:rPr lang="fr-FR" smtClean="0"/>
-              <a:t>08/08/2026</a:t>
+              <a:t>11/08/2026</a:t>
             </a:fld>
             <a:endParaRPr lang="fr-FR"/>
           </a:p>
@@ -471,7 +471,7 @@
           <a:p>
             <a:fld id="{C160A1AF-E65B-EC4B-9788-C7116365DFF5}" type="datetimeFigureOut">
               <a:rPr lang="fr-FR" smtClean="0"/>
-              <a:t>08/08/2026</a:t>
+              <a:t>11/08/2026</a:t>
             </a:fld>
             <a:endParaRPr lang="fr-FR"/>
           </a:p>
@@ -681,7 +681,7 @@
           <a:p>
             <a:fld id="{C160A1AF-E65B-EC4B-9788-C7116365DFF5}" type="datetimeFigureOut">
               <a:rPr lang="fr-FR" smtClean="0"/>
-              <a:t>08/08/2026</a:t>
+              <a:t>11/08/2026</a:t>
             </a:fld>
             <a:endParaRPr lang="fr-FR"/>
           </a:p>
@@ -881,7 +881,7 @@
           <a:p>
             <a:fld id="{C160A1AF-E65B-EC4B-9788-C7116365DFF5}" type="datetimeFigureOut">
               <a:rPr lang="fr-FR" smtClean="0"/>
-              <a:t>08/08/2026</a:t>
+              <a:t>11/08/2026</a:t>
             </a:fld>
             <a:endParaRPr lang="fr-FR"/>
           </a:p>
@@ -1157,7 +1157,7 @@
           <a:p>
             <a:fld id="{C160A1AF-E65B-EC4B-9788-C7116365DFF5}" type="datetimeFigureOut">
               <a:rPr lang="fr-FR" smtClean="0"/>
-              <a:t>08/08/2026</a:t>
+              <a:t>11/08/2026</a:t>
             </a:fld>
             <a:endParaRPr lang="fr-FR"/>
           </a:p>
@@ -1425,7 +1425,7 @@
           <a:p>
             <a:fld id="{C160A1AF-E65B-EC4B-9788-C7116365DFF5}" type="datetimeFigureOut">
               <a:rPr lang="fr-FR" smtClean="0"/>
-              <a:t>08/08/2026</a:t>
+              <a:t>11/08/2026</a:t>
             </a:fld>
             <a:endParaRPr lang="fr-FR"/>
           </a:p>
@@ -1840,7 +1840,7 @@
           <a:p>
             <a:fld id="{C160A1AF-E65B-EC4B-9788-C7116365DFF5}" type="datetimeFigureOut">
               <a:rPr lang="fr-FR" smtClean="0"/>
-              <a:t>08/08/2026</a:t>
+              <a:t>11/08/2026</a:t>
             </a:fld>
             <a:endParaRPr lang="fr-FR"/>
           </a:p>
@@ -1982,7 +1982,7 @@
           <a:p>
             <a:fld id="{C160A1AF-E65B-EC4B-9788-C7116365DFF5}" type="datetimeFigureOut">
               <a:rPr lang="fr-FR" smtClean="0"/>
-              <a:t>08/08/2026</a:t>
+              <a:t>11/08/2026</a:t>
             </a:fld>
             <a:endParaRPr lang="fr-FR"/>
           </a:p>
@@ -2095,7 +2095,7 @@
           <a:p>
             <a:fld id="{C160A1AF-E65B-EC4B-9788-C7116365DFF5}" type="datetimeFigureOut">
               <a:rPr lang="fr-FR" smtClean="0"/>
-              <a:t>08/08/2026</a:t>
+              <a:t>11/08/2026</a:t>
             </a:fld>
             <a:endParaRPr lang="fr-FR"/>
           </a:p>
@@ -2408,7 +2408,7 @@
           <a:p>
             <a:fld id="{C160A1AF-E65B-EC4B-9788-C7116365DFF5}" type="datetimeFigureOut">
               <a:rPr lang="fr-FR" smtClean="0"/>
-              <a:t>08/08/2026</a:t>
+              <a:t>11/08/2026</a:t>
             </a:fld>
             <a:endParaRPr lang="fr-FR"/>
           </a:p>
@@ -2697,7 +2697,7 @@
           <a:p>
             <a:fld id="{C160A1AF-E65B-EC4B-9788-C7116365DFF5}" type="datetimeFigureOut">
               <a:rPr lang="fr-FR" smtClean="0"/>
-              <a:t>08/08/2026</a:t>
+              <a:t>11/08/2026</a:t>
             </a:fld>
             <a:endParaRPr lang="fr-FR"/>
           </a:p>
@@ -2940,7 +2940,7 @@
           <a:p>
             <a:fld id="{C160A1AF-E65B-EC4B-9788-C7116365DFF5}" type="datetimeFigureOut">
               <a:rPr lang="fr-FR" smtClean="0"/>
-              <a:t>08/08/2026</a:t>
+              <a:t>11/08/2026</a:t>
             </a:fld>
             <a:endParaRPr lang="fr-FR"/>
           </a:p>
@@ -3796,7 +3796,7 @@
         <p:spPr/>
         <p:txBody>
           <a:bodyPr>
-            <a:normAutofit fontScale="92500"/>
+            <a:normAutofit lnSpcReduction="10000"/>
           </a:bodyPr>
           <a:lstStyle/>
           <a:p>
@@ -3818,7 +3818,7 @@
           <a:p>
             <a:r>
               <a:rPr lang="fr-FR" dirty="0"/>
-              <a:t>Urgence prononcée de trouver une solution viable.  </a:t>
+              <a:t>La nécessité de trouver une solution effective est prononcée.  </a:t>
             </a:r>
           </a:p>
           <a:p>
@@ -3842,14 +3842,22 @@
           </a:p>
           <a:p>
             <a:r>
-              <a:rPr lang="fr-FR" dirty="0"/>
-              <a:t>Réponse RH =&gt;   embauche</a:t>
-            </a:r>
-          </a:p>
-          <a:p>
-            <a:r>
-              <a:rPr lang="fr-FR" dirty="0"/>
-              <a:t>Réponse technique =&gt; IA (agent intelligent d’accueil et d’orientation)</a:t>
+              <a:rPr lang="fr-FR" dirty="0" err="1"/>
+              <a:t>Hyp</a:t>
+            </a:r>
+            <a:r>
+              <a:rPr lang="fr-FR" dirty="0"/>
+              <a:t>.  RH =&gt;   embauche de nouveaux personnels. </a:t>
+            </a:r>
+          </a:p>
+          <a:p>
+            <a:r>
+              <a:rPr lang="fr-FR" dirty="0" err="1"/>
+              <a:t>Hyp</a:t>
+            </a:r>
+            <a:r>
+              <a:rPr lang="fr-FR" dirty="0"/>
+              <a:t>.  technique =&gt; IA (agent intelligent d’accueil et d’orientation)</a:t>
             </a:r>
           </a:p>
         </p:txBody>
@@ -3907,7 +3915,7 @@
           <a:p>
             <a:r>
               <a:rPr lang="fr-FR" dirty="0"/>
-              <a:t>Méthode : implémentation d’un POC </a:t>
+              <a:t>Méthode : implémentation du POC </a:t>
             </a:r>
           </a:p>
         </p:txBody>
@@ -3937,13 +3945,30 @@
               <a:buNone/>
             </a:pPr>
             <a:r>
-              <a:rPr lang="fr-FR" dirty="0" err="1"/>
+              <a:rPr lang="fr-FR" b="1" dirty="0" err="1"/>
+              <a:t>AIOps</a:t>
+            </a:r>
+            <a:r>
+              <a:rPr lang="fr-FR" b="1" dirty="0"/>
+              <a:t> = </a:t>
+            </a:r>
+            <a:r>
+              <a:rPr lang="fr-FR" b="1" dirty="0" err="1"/>
               <a:t>MLOPs</a:t>
             </a:r>
             <a:r>
-              <a:rPr lang="fr-FR" dirty="0"/>
-              <a:t> :</a:t>
-            </a:r>
+              <a:rPr lang="fr-FR" b="1" dirty="0"/>
+              <a:t>  + </a:t>
+            </a:r>
+            <a:r>
+              <a:rPr lang="fr-FR" b="1" dirty="0" err="1"/>
+              <a:t>AgentOps</a:t>
+            </a:r>
+            <a:r>
+              <a:rPr lang="fr-FR" b="1" dirty="0"/>
+              <a:t> </a:t>
+            </a:r>
+            <a:endParaRPr lang="fr-FR" dirty="0"/>
           </a:p>
           <a:p>
             <a:pPr>
@@ -3995,7 +4020,7 @@
             </a:pPr>
             <a:r>
               <a:rPr lang="fr-FR" dirty="0"/>
-              <a:t> Implémentation d’un agent IA</a:t>
+              <a:t> Implémentation de  l’agent de triage</a:t>
             </a:r>
           </a:p>
           <a:p>
@@ -4104,12 +4129,12 @@
               <a:buNone/>
             </a:pPr>
             <a:r>
-              <a:rPr lang="fr-FR" dirty="0" err="1"/>
-              <a:t>MLOPs</a:t>
-            </a:r>
-            <a:r>
-              <a:rPr lang="fr-FR" dirty="0"/>
-              <a:t> :</a:t>
+              <a:rPr lang="fr-FR" dirty="0"/>
+              <a:t> </a:t>
+            </a:r>
+            <a:r>
+              <a:rPr lang="fr-FR" u="sng" dirty="0"/>
+              <a:t>Acquisition des données:</a:t>
             </a:r>
           </a:p>
           <a:p>
@@ -4119,15 +4144,7 @@
             </a:pPr>
             <a:r>
               <a:rPr lang="fr-FR" dirty="0"/>
-              <a:t>Collecte,  inspection  et préparation des données </a:t>
-            </a:r>
-            <a:r>
-              <a:rPr lang="fr-FR" dirty="0" err="1"/>
-              <a:t>depyis</a:t>
-            </a:r>
-            <a:r>
-              <a:rPr lang="fr-FR" dirty="0"/>
-              <a:t> les différentes sources suivantes :</a:t>
+              <a:t>Collecte,  inspection  et préparation des données depuis les différentes sources suivantes :</a:t>
             </a:r>
           </a:p>
           <a:p>
@@ -4280,22 +4297,22 @@
           </a:bodyPr>
           <a:lstStyle/>
           <a:p>
+            <a:pPr marL="0" indent="0">
+              <a:buNone/>
+            </a:pPr>
+            <a:r>
+              <a:rPr lang="fr-FR" u="sng" dirty="0"/>
+              <a:t>Entraînement : </a:t>
+            </a:r>
+          </a:p>
+          <a:p>
             <a:pPr>
               <a:buFont typeface="Wingdings" pitchFamily="2" charset="2"/>
               <a:buChar char="Ø"/>
             </a:pPr>
             <a:r>
               <a:rPr lang="fr-FR" dirty="0"/>
-              <a:t>Entraînement : </a:t>
-            </a:r>
-          </a:p>
-          <a:p>
-            <a:pPr marL="0" indent="0">
-              <a:buNone/>
-            </a:pPr>
-            <a:r>
-              <a:rPr lang="fr-FR" dirty="0"/>
-              <a:t>          - SFT + </a:t>
+              <a:t>           SFT + </a:t>
             </a:r>
             <a:r>
               <a:rPr lang="fr-FR" dirty="0" err="1"/>
@@ -4361,12 +4378,13 @@
             <a:endParaRPr lang="fr-FR" dirty="0"/>
           </a:p>
           <a:p>
-            <a:pPr marL="0" indent="0">
-              <a:buNone/>
+            <a:pPr>
+              <a:buFont typeface="Wingdings" pitchFamily="2" charset="2"/>
+              <a:buChar char="Ø"/>
             </a:pPr>
             <a:r>
               <a:rPr lang="fr-FR" dirty="0"/>
-              <a:t>           - Alignement : DPO </a:t>
+              <a:t>            Alignement : DPO </a:t>
             </a:r>
           </a:p>
           <a:p>
@@ -4500,9 +4518,18 @@
         <p:spPr/>
         <p:txBody>
           <a:bodyPr>
-            <a:normAutofit fontScale="92500" lnSpcReduction="10000"/>
+            <a:normAutofit lnSpcReduction="10000"/>
           </a:bodyPr>
           <a:lstStyle/>
+          <a:p>
+            <a:pPr marL="0" indent="0">
+              <a:buNone/>
+            </a:pPr>
+            <a:r>
+              <a:rPr lang="fr-FR" u="sng" dirty="0"/>
+              <a:t>Implémentation d’un agent IA</a:t>
+            </a:r>
+          </a:p>
           <a:p>
             <a:pPr>
               <a:buFont typeface="Wingdings" pitchFamily="2" charset="2"/>
@@ -4510,7 +4537,46 @@
             </a:pPr>
             <a:r>
               <a:rPr lang="fr-FR" dirty="0"/>
-              <a:t>Implémentation d’un agent IA</a:t>
+              <a:t> Centre logique </a:t>
+            </a:r>
+          </a:p>
+          <a:p>
+            <a:pPr marL="0" indent="0">
+              <a:buNone/>
+            </a:pPr>
+            <a:r>
+              <a:rPr lang="fr-FR" dirty="0"/>
+              <a:t>  - moteur d’inférence : </a:t>
+            </a:r>
+            <a:r>
+              <a:rPr lang="fr-FR" dirty="0" err="1"/>
+              <a:t>vllm</a:t>
+            </a:r>
+            <a:r>
+              <a:rPr lang="fr-FR" dirty="0"/>
+              <a:t> + </a:t>
+            </a:r>
+            <a:r>
+              <a:rPr lang="fr-FR" dirty="0" err="1"/>
+              <a:t>llm</a:t>
+            </a:r>
+            <a:endParaRPr lang="fr-FR" dirty="0"/>
+          </a:p>
+          <a:p>
+            <a:pPr marL="0" indent="0">
+              <a:buNone/>
+            </a:pPr>
+            <a:r>
+              <a:rPr lang="fr-FR" dirty="0"/>
+              <a:t>  - </a:t>
+            </a:r>
+            <a:r>
+              <a:rPr lang="fr-FR" dirty="0" err="1"/>
+              <a:t>llm</a:t>
+            </a:r>
+            <a:r>
+              <a:rPr lang="fr-FR" dirty="0"/>
+              <a:t> : Qwen3-1.7B-Base + modèle entraîné</a:t>
             </a:r>
           </a:p>
           <a:p>
@@ -4520,7 +4586,24 @@
             </a:pPr>
             <a:r>
               <a:rPr lang="fr-FR" dirty="0"/>
-              <a:t> Alignement  du modèle sur les poids entraînés </a:t>
+              <a:t> Orchestrateur : </a:t>
+            </a:r>
+          </a:p>
+          <a:p>
+            <a:pPr marL="0" indent="0">
+              <a:buNone/>
+            </a:pPr>
+            <a:r>
+              <a:rPr lang="fr-FR" dirty="0"/>
+              <a:t>  - API : </a:t>
+            </a:r>
+            <a:r>
+              <a:rPr lang="fr-FR" dirty="0" err="1"/>
+              <a:t>fastAPI</a:t>
+            </a:r>
+            <a:r>
+              <a:rPr lang="fr-FR" dirty="0"/>
+              <a:t>  </a:t>
             </a:r>
           </a:p>
           <a:p>
@@ -4530,16 +4613,15 @@
             </a:pPr>
             <a:r>
               <a:rPr lang="fr-FR" dirty="0"/>
-              <a:t> test (CI-dev) </a:t>
-            </a:r>
-          </a:p>
-          <a:p>
-            <a:pPr marL="0" indent="0">
-              <a:buNone/>
-            </a:pPr>
-            <a:r>
-              <a:rPr lang="fr-FR" dirty="0"/>
-              <a:t>  - moteur d’inférence : </a:t>
+              <a:t> Outil : UI (</a:t>
+            </a:r>
+            <a:r>
+              <a:rPr lang="fr-FR" dirty="0" err="1"/>
+              <a:t>streamlit</a:t>
+            </a:r>
+            <a:r>
+              <a:rPr lang="fr-FR" dirty="0"/>
+              <a:t>) + </a:t>
             </a:r>
             <a:r>
               <a:rPr lang="fr-FR" dirty="0" err="1"/>
@@ -4551,118 +4633,15 @@
             <a:pPr marL="0" indent="0">
               <a:buNone/>
             </a:pPr>
-            <a:r>
-              <a:rPr lang="fr-FR" dirty="0"/>
-              <a:t>  - </a:t>
-            </a:r>
-            <a:r>
-              <a:rPr lang="fr-FR" dirty="0" err="1"/>
-              <a:t>llm</a:t>
-            </a:r>
-            <a:r>
-              <a:rPr lang="fr-FR" dirty="0"/>
-              <a:t> : Qwen3-1.7B-Base + modèle entraîné</a:t>
-            </a:r>
-          </a:p>
-          <a:p>
-            <a:pPr>
-              <a:buFont typeface="Wingdings" pitchFamily="2" charset="2"/>
-              <a:buChar char="Ø"/>
+            <a:endParaRPr lang="fr-FR" dirty="0"/>
+          </a:p>
+          <a:p>
+            <a:pPr marL="0" indent="0">
+              <a:buNone/>
             </a:pPr>
             <a:r>
               <a:rPr lang="fr-FR" dirty="0"/>
-              <a:t> Déploiement (CI/CD) : micro services sur Google cloud </a:t>
-            </a:r>
-            <a:r>
-              <a:rPr lang="fr-FR" dirty="0" err="1"/>
-              <a:t>plateform</a:t>
-            </a:r>
-            <a:r>
-              <a:rPr lang="fr-FR" dirty="0"/>
-              <a:t> (GCP)+ déclencheurs </a:t>
-            </a:r>
-            <a:r>
-              <a:rPr lang="fr-FR" dirty="0" err="1"/>
-              <a:t>gcp</a:t>
-            </a:r>
-            <a:r>
-              <a:rPr lang="fr-FR" dirty="0"/>
               <a:t> </a:t>
-            </a:r>
-            <a:r>
-              <a:rPr lang="fr-FR" dirty="0" err="1"/>
-              <a:t>build</a:t>
-            </a:r>
-            <a:r>
-              <a:rPr lang="fr-FR" dirty="0"/>
-              <a:t> service. </a:t>
-            </a:r>
-          </a:p>
-          <a:p>
-            <a:pPr marL="0" indent="0">
-              <a:buNone/>
-            </a:pPr>
-            <a:r>
-              <a:rPr lang="fr-FR" dirty="0"/>
-              <a:t> - cloud </a:t>
-            </a:r>
-            <a:r>
-              <a:rPr lang="fr-FR" dirty="0" err="1"/>
-              <a:t>storage</a:t>
-            </a:r>
-            <a:r>
-              <a:rPr lang="fr-FR" dirty="0"/>
-              <a:t> (artefact </a:t>
-            </a:r>
-            <a:r>
-              <a:rPr lang="fr-FR" dirty="0" err="1"/>
-              <a:t>registry</a:t>
-            </a:r>
-            <a:r>
-              <a:rPr lang="fr-FR" dirty="0"/>
-              <a:t> : google </a:t>
-            </a:r>
-            <a:r>
-              <a:rPr lang="fr-FR" dirty="0" err="1"/>
-              <a:t>bucket</a:t>
-            </a:r>
-            <a:r>
-              <a:rPr lang="fr-FR" dirty="0"/>
-              <a:t> pour le modèle </a:t>
-            </a:r>
-            <a:r>
-              <a:rPr lang="fr-FR" dirty="0" err="1"/>
-              <a:t>entr</a:t>
-            </a:r>
-            <a:r>
-              <a:rPr lang="fr-FR" dirty="0"/>
-              <a:t>.)</a:t>
-            </a:r>
-          </a:p>
-          <a:p>
-            <a:pPr marL="0" indent="0">
-              <a:buNone/>
-            </a:pPr>
-            <a:r>
-              <a:rPr lang="fr-FR" dirty="0"/>
-              <a:t> - cloud </a:t>
-            </a:r>
-            <a:r>
-              <a:rPr lang="fr-FR" dirty="0" err="1"/>
-              <a:t>build</a:t>
-            </a:r>
-            <a:r>
-              <a:rPr lang="fr-FR" dirty="0"/>
-              <a:t> : construction des conteneurs docker</a:t>
-            </a:r>
-          </a:p>
-          <a:p>
-            <a:pPr marL="0" indent="0">
-              <a:buNone/>
-            </a:pPr>
-            <a:r>
-              <a:rPr lang="fr-FR" dirty="0"/>
-              <a:t>- cloud run : déploiement des conteneurs</a:t>
             </a:r>
           </a:p>
         </p:txBody>

</xml_diff>